<commit_message>
Slides: sd-06-009 slide 7 asks for the policy check first; re-export PPTX
Co-Authored-By: Claude Sonnet 5.5 <noreply@anthropic.com>
Claude-Session: https://claude.ai/code/session_01XSxLqDPHaDeZhrxWwesxJf
</commit_message>
<xml_diff>
--- a/system-design-101/vi/lessons/sd-06-009/slides/sd-06-009.pptx
+++ b/system-design-101/vi/lessons/sd-06-009/slides/sd-06-009.pptx
@@ -9099,7 +9099,7 @@
               <a:t>Xem</a:t>
             </a:r>
             <a:r>
-              <a:rPr lang="en-US" sz="3600" dirty="0" spc="-17" kern="0">
+              <a:rPr lang="en-US" sz="3600" dirty="0" spc="2" kern="0">
                 <a:solidFill>
                   <a:srgbClr val="3DD6A0"/>
                 </a:solidFill>
@@ -9107,10 +9107,10 @@
                 <a:ea typeface="Bricolage Grotesque ExtraBold" pitchFamily="34" charset="-122"/>
                 <a:cs typeface="Bricolage Grotesque ExtraBold" pitchFamily="34" charset="-120"/>
               </a:rPr>
-              <a:t> evicted_keys</a:t>
-            </a:r>
-            <a:r>
-              <a:rPr lang="en-US" sz="3600" dirty="0" spc="1" kern="0">
+              <a:t> chính sách</a:t>
+            </a:r>
+            <a:r>
+              <a:rPr lang="en-US" sz="3600" dirty="0" spc="-39" kern="0">
                 <a:solidFill>
                   <a:srgbClr val="3DD6A0"/>
                 </a:solidFill>
@@ -9118,18 +9118,7 @@
                 <a:ea typeface="Bricolage Grotesque ExtraBold" pitchFamily="34" charset="-122"/>
                 <a:cs typeface="Bricolage Grotesque ExtraBold" pitchFamily="34" charset="-120"/>
               </a:rPr>
-              <a:t> tăng bao</a:t>
-            </a:r>
-            <a:r>
-              <a:rPr lang="en-US" sz="3600" dirty="0" spc="3" kern="0">
-                <a:solidFill>
-                  <a:srgbClr val="3DD6A0"/>
-                </a:solidFill>
-                <a:latin typeface="Bricolage Grotesque ExtraBold" pitchFamily="34" charset="0"/>
-                <a:ea typeface="Bricolage Grotesque ExtraBold" pitchFamily="34" charset="-122"/>
-                <a:cs typeface="Bricolage Grotesque ExtraBold" pitchFamily="34" charset="-120"/>
-              </a:rPr>
-              <a:t> nhiêu</a:t>
+              <a:t> trước</a:t>
             </a:r>
             <a:endParaRPr lang="en-US" sz="3600" dirty="0"/>
           </a:p>
@@ -9168,15 +9157,70 @@
               <a:buChar char="•"/>
             </a:pPr>
             <a:r>
-              <a:rPr lang="en-US" sz="2700" dirty="0" spc="-60" kern="0">
-                <a:solidFill>
-                  <a:srgbClr val="E4E1D8"/>
-                </a:solidFill>
-                <a:latin typeface="Be Vietnam Pro" pitchFamily="34" charset="0"/>
-                <a:ea typeface="Be Vietnam Pro" pitchFamily="34" charset="-122"/>
-                <a:cs typeface="Be Vietnam Pro" pitchFamily="34" charset="-120"/>
-              </a:rPr>
-              <a:t>Tăng</a:t>
+              <a:rPr lang="en-US" sz="2700" dirty="0" spc="-37" kern="0">
+                <a:solidFill>
+                  <a:srgbClr val="E4E1D8"/>
+                </a:solidFill>
+                <a:latin typeface="Be Vietnam Pro" pitchFamily="34" charset="0"/>
+                <a:ea typeface="Be Vietnam Pro" pitchFamily="34" charset="-122"/>
+                <a:cs typeface="Be Vietnam Pro" pitchFamily="34" charset="-120"/>
+              </a:rPr>
+              <a:t>Xem</a:t>
+            </a:r>
+            <a:r>
+              <a:rPr lang="en-US" sz="2700" dirty="0" spc="-7" kern="0">
+                <a:solidFill>
+                  <a:srgbClr val="E4E1D8"/>
+                </a:solidFill>
+                <a:latin typeface="Be Vietnam Pro" pitchFamily="34" charset="0"/>
+                <a:ea typeface="Be Vietnam Pro" pitchFamily="34" charset="-122"/>
+                <a:cs typeface="Be Vietnam Pro" pitchFamily="34" charset="-120"/>
+              </a:rPr>
+              <a:t> maxmemory-policy</a:t>
+            </a:r>
+            <a:r>
+              <a:rPr lang="en-US" sz="2700" dirty="0" spc="-15" kern="0">
+                <a:solidFill>
+                  <a:srgbClr val="E4E1D8"/>
+                </a:solidFill>
+                <a:latin typeface="Be Vietnam Pro" pitchFamily="34" charset="0"/>
+                <a:ea typeface="Be Vietnam Pro" pitchFamily="34" charset="-122"/>
+                <a:cs typeface="Be Vietnam Pro" pitchFamily="34" charset="-120"/>
+              </a:rPr>
+              <a:t> và</a:t>
+            </a:r>
+            <a:r>
+              <a:rPr lang="en-US" sz="2700" dirty="0" spc="-7" kern="0">
+                <a:solidFill>
+                  <a:srgbClr val="E4E1D8"/>
+                </a:solidFill>
+                <a:latin typeface="Be Vietnam Pro" pitchFamily="34" charset="0"/>
+                <a:ea typeface="Be Vietnam Pro" pitchFamily="34" charset="-122"/>
+                <a:cs typeface="Be Vietnam Pro" pitchFamily="34" charset="-120"/>
+              </a:rPr>
+              <a:t> bộ</a:t>
+            </a:r>
+            <a:r>
+              <a:rPr lang="en-US" sz="2700" dirty="0" spc="-2" kern="0">
+                <a:solidFill>
+                  <a:srgbClr val="E4E1D8"/>
+                </a:solidFill>
+                <a:latin typeface="Be Vietnam Pro" pitchFamily="34" charset="0"/>
+                <a:ea typeface="Be Vietnam Pro" pitchFamily="34" charset="-122"/>
+                <a:cs typeface="Be Vietnam Pro" pitchFamily="34" charset="-120"/>
+              </a:rPr>
+              <a:t> nhớ</a:t>
+            </a:r>
+            <a:r>
+              <a:rPr lang="en-US" sz="2700" dirty="0" spc="16" kern="0">
+                <a:solidFill>
+                  <a:srgbClr val="E4E1D8"/>
+                </a:solidFill>
+                <a:latin typeface="Be Vietnam Pro" pitchFamily="34" charset="0"/>
+                <a:ea typeface="Be Vietnam Pro" pitchFamily="34" charset="-122"/>
+                <a:cs typeface="Be Vietnam Pro" pitchFamily="34" charset="-120"/>
+              </a:rPr>
+              <a:t> đã</a:t>
             </a:r>
             <a:r>
               <a:rPr lang="en-US" sz="2700" dirty="0" spc="-3" kern="0">
@@ -9187,73 +9231,7 @@
                 <a:ea typeface="Be Vietnam Pro" pitchFamily="34" charset="-122"/>
                 <a:cs typeface="Be Vietnam Pro" pitchFamily="34" charset="-120"/>
               </a:rPr>
-              <a:t> nhanh:</a:t>
-            </a:r>
-            <a:r>
-              <a:rPr lang="en-US" sz="2700" dirty="0" spc="-1" kern="0">
-                <a:solidFill>
-                  <a:srgbClr val="E4E1D8"/>
-                </a:solidFill>
-                <a:latin typeface="Be Vietnam Pro" pitchFamily="34" charset="0"/>
-                <a:ea typeface="Be Vietnam Pro" pitchFamily="34" charset="-122"/>
-                <a:cs typeface="Be Vietnam Pro" pitchFamily="34" charset="-120"/>
-              </a:rPr>
-              <a:t> thêm</a:t>
-            </a:r>
-            <a:r>
-              <a:rPr lang="en-US" sz="2700" dirty="0" spc="-7" kern="0">
-                <a:solidFill>
-                  <a:srgbClr val="E4E1D8"/>
-                </a:solidFill>
-                <a:latin typeface="Be Vietnam Pro" pitchFamily="34" charset="0"/>
-                <a:ea typeface="Be Vietnam Pro" pitchFamily="34" charset="-122"/>
-                <a:cs typeface="Be Vietnam Pro" pitchFamily="34" charset="-120"/>
-              </a:rPr>
-              <a:t> bộ</a:t>
-            </a:r>
-            <a:r>
-              <a:rPr lang="en-US" sz="2700" dirty="0" spc="-3" kern="0">
-                <a:solidFill>
-                  <a:srgbClr val="E4E1D8"/>
-                </a:solidFill>
-                <a:latin typeface="Be Vietnam Pro" pitchFamily="34" charset="0"/>
-                <a:ea typeface="Be Vietnam Pro" pitchFamily="34" charset="-122"/>
-                <a:cs typeface="Be Vietnam Pro" pitchFamily="34" charset="-120"/>
-              </a:rPr>
-              <a:t> nhớ</a:t>
-            </a:r>
-            <a:r>
-              <a:rPr lang="en-US" sz="2700" dirty="0" spc="0" kern="0">
-                <a:solidFill>
-                  <a:srgbClr val="E4E1D8"/>
-                </a:solidFill>
-                <a:latin typeface="Be Vietnam Pro" pitchFamily="34" charset="0"/>
-                <a:ea typeface="Be Vietnam Pro" pitchFamily="34" charset="-122"/>
-                <a:cs typeface="Be Vietnam Pro" pitchFamily="34" charset="-120"/>
-              </a:rPr>
-              <a:t> có</a:t>
-            </a:r>
-            <a:r>
-              <a:rPr lang="en-US" sz="2700" dirty="0" spc="-1" kern="0">
-                <a:solidFill>
-                  <a:srgbClr val="E4E1D8"/>
-                </a:solidFill>
-                <a:latin typeface="Be Vietnam Pro" pitchFamily="34" charset="0"/>
-                <a:ea typeface="Be Vietnam Pro" pitchFamily="34" charset="-122"/>
-                <a:cs typeface="Be Vietnam Pro" pitchFamily="34" charset="-120"/>
-              </a:rPr>
-              <a:t> thể</a:t>
-            </a:r>
-            <a:r>
-              <a:rPr lang="en-US" sz="2700" dirty="0" spc="-3" kern="0">
-                <a:solidFill>
-                  <a:srgbClr val="E4E1D8"/>
-                </a:solidFill>
-                <a:latin typeface="Be Vietnam Pro" pitchFamily="34" charset="0"/>
-                <a:ea typeface="Be Vietnam Pro" pitchFamily="34" charset="-122"/>
-                <a:cs typeface="Be Vietnam Pro" pitchFamily="34" charset="-120"/>
-              </a:rPr>
-              <a:t> giúp</a:t>
+              <a:t> dùng</a:t>
             </a:r>
             <a:endParaRPr lang="en-US" sz="2700" dirty="0"/>
           </a:p>
@@ -9270,6 +9248,94 @@
               <a:buChar char="•"/>
             </a:pPr>
             <a:r>
+              <a:rPr lang="en-US" sz="2700" dirty="0" spc="-5" kern="0">
+                <a:solidFill>
+                  <a:srgbClr val="E4E1D8"/>
+                </a:solidFill>
+                <a:latin typeface="Be Vietnam Pro" pitchFamily="34" charset="0"/>
+                <a:ea typeface="Be Vietnam Pro" pitchFamily="34" charset="-122"/>
+                <a:cs typeface="Be Vietnam Pro" pitchFamily="34" charset="-120"/>
+              </a:rPr>
+              <a:t>noeviction,</a:t>
+            </a:r>
+            <a:r>
+              <a:rPr lang="en-US" sz="2700" dirty="0" spc="-10" kern="0">
+                <a:solidFill>
+                  <a:srgbClr val="E4E1D8"/>
+                </a:solidFill>
+                <a:latin typeface="Be Vietnam Pro" pitchFamily="34" charset="0"/>
+                <a:ea typeface="Be Vietnam Pro" pitchFamily="34" charset="-122"/>
+                <a:cs typeface="Be Vietnam Pro" pitchFamily="34" charset="-120"/>
+              </a:rPr>
+              <a:t> volatile:</a:t>
+            </a:r>
+            <a:r>
+              <a:rPr lang="en-US" sz="2700" dirty="0" spc="-27" kern="0">
+                <a:solidFill>
+                  <a:srgbClr val="E4E1D8"/>
+                </a:solidFill>
+                <a:latin typeface="Be Vietnam Pro" pitchFamily="34" charset="0"/>
+                <a:ea typeface="Be Vietnam Pro" pitchFamily="34" charset="-122"/>
+                <a:cs typeface="Be Vietnam Pro" pitchFamily="34" charset="-120"/>
+              </a:rPr>
+              <a:t> evicted_keys</a:t>
+            </a:r>
+            <a:r>
+              <a:rPr lang="en-US" sz="2700" dirty="0" spc="-2" kern="0">
+                <a:solidFill>
+                  <a:srgbClr val="E4E1D8"/>
+                </a:solidFill>
+                <a:latin typeface="Be Vietnam Pro" pitchFamily="34" charset="0"/>
+                <a:ea typeface="Be Vietnam Pro" pitchFamily="34" charset="-122"/>
+                <a:cs typeface="Be Vietnam Pro" pitchFamily="34" charset="-120"/>
+              </a:rPr>
+              <a:t> luôn</a:t>
+            </a:r>
+            <a:r>
+              <a:rPr lang="en-US" sz="2700" dirty="0" spc="1" kern="0">
+                <a:solidFill>
+                  <a:srgbClr val="E4E1D8"/>
+                </a:solidFill>
+                <a:latin typeface="Be Vietnam Pro" pitchFamily="34" charset="0"/>
+                <a:ea typeface="Be Vietnam Pro" pitchFamily="34" charset="-122"/>
+                <a:cs typeface="Be Vietnam Pro" pitchFamily="34" charset="-120"/>
+              </a:rPr>
+              <a:t> 0,</a:t>
+            </a:r>
+            <a:r>
+              <a:rPr lang="en-US" sz="2700" dirty="0" spc="-21" kern="0">
+                <a:solidFill>
+                  <a:srgbClr val="E4E1D8"/>
+                </a:solidFill>
+                <a:latin typeface="Be Vietnam Pro" pitchFamily="34" charset="0"/>
+                <a:ea typeface="Be Vietnam Pro" pitchFamily="34" charset="-122"/>
+                <a:cs typeface="Be Vietnam Pro" pitchFamily="34" charset="-120"/>
+              </a:rPr>
+              <a:t> xem</a:t>
+            </a:r>
+            <a:r>
+              <a:rPr lang="en-US" sz="2700" dirty="0" spc="-3" kern="0">
+                <a:solidFill>
+                  <a:srgbClr val="E4E1D8"/>
+                </a:solidFill>
+                <a:latin typeface="Be Vietnam Pro" pitchFamily="34" charset="0"/>
+                <a:ea typeface="Be Vietnam Pro" pitchFamily="34" charset="-122"/>
+                <a:cs typeface="Be Vietnam Pro" pitchFamily="34" charset="-120"/>
+              </a:rPr>
+              <a:t> lệnh bị</a:t>
+            </a:r>
+            <a:r>
+              <a:rPr lang="en-US" sz="2700" dirty="0" spc="-1" kern="0">
+                <a:solidFill>
+                  <a:srgbClr val="E4E1D8"/>
+                </a:solidFill>
+                <a:latin typeface="Be Vietnam Pro" pitchFamily="34" charset="0"/>
+                <a:ea typeface="Be Vietnam Pro" pitchFamily="34" charset="-122"/>
+                <a:cs typeface="Be Vietnam Pro" pitchFamily="34" charset="-120"/>
+              </a:rPr>
+              <a:t> từ</a:t>
+            </a:r>
+            <a:r>
               <a:rPr lang="en-US" sz="2700" dirty="0" spc="0" kern="0">
                 <a:solidFill>
                   <a:srgbClr val="E4E1D8"/>
@@ -9278,106 +9344,7 @@
                 <a:ea typeface="Be Vietnam Pro" pitchFamily="34" charset="-122"/>
                 <a:cs typeface="Be Vietnam Pro" pitchFamily="34" charset="-120"/>
               </a:rPr>
-              <a:t>Gần</a:t>
-            </a:r>
-            <a:r>
-              <a:rPr lang="en-US" sz="2700" dirty="0" spc="-1" kern="0">
-                <a:solidFill>
-                  <a:srgbClr val="E4E1D8"/>
-                </a:solidFill>
-                <a:latin typeface="Be Vietnam Pro" pitchFamily="34" charset="0"/>
-                <a:ea typeface="Be Vietnam Pro" pitchFamily="34" charset="-122"/>
-                <a:cs typeface="Be Vietnam Pro" pitchFamily="34" charset="-120"/>
-              </a:rPr>
-              <a:t> như</a:t>
-            </a:r>
-            <a:r>
-              <a:rPr lang="en-US" sz="2700" dirty="0" spc="-2" kern="0">
-                <a:solidFill>
-                  <a:srgbClr val="E4E1D8"/>
-                </a:solidFill>
-                <a:latin typeface="Be Vietnam Pro" pitchFamily="34" charset="0"/>
-                <a:ea typeface="Be Vietnam Pro" pitchFamily="34" charset="-122"/>
-                <a:cs typeface="Be Vietnam Pro" pitchFamily="34" charset="-120"/>
-              </a:rPr>
-              <a:t> không</a:t>
-            </a:r>
-            <a:r>
-              <a:rPr lang="en-US" sz="2700" dirty="0" spc="-10" kern="0">
-                <a:solidFill>
-                  <a:srgbClr val="E4E1D8"/>
-                </a:solidFill>
-                <a:latin typeface="Be Vietnam Pro" pitchFamily="34" charset="0"/>
-                <a:ea typeface="Be Vietnam Pro" pitchFamily="34" charset="-122"/>
-                <a:cs typeface="Be Vietnam Pro" pitchFamily="34" charset="-120"/>
-              </a:rPr>
-              <a:t> tăng:</a:t>
-            </a:r>
-            <a:r>
-              <a:rPr lang="en-US" sz="2700" dirty="0" spc="-1" kern="0">
-                <a:solidFill>
-                  <a:srgbClr val="E4E1D8"/>
-                </a:solidFill>
-                <a:latin typeface="Be Vietnam Pro" pitchFamily="34" charset="0"/>
-                <a:ea typeface="Be Vietnam Pro" pitchFamily="34" charset="-122"/>
-                <a:cs typeface="Be Vietnam Pro" pitchFamily="34" charset="-120"/>
-              </a:rPr>
-              <a:t> thêm</a:t>
-            </a:r>
-            <a:r>
-              <a:rPr lang="en-US" sz="2700" dirty="0" spc="-7" kern="0">
-                <a:solidFill>
-                  <a:srgbClr val="E4E1D8"/>
-                </a:solidFill>
-                <a:latin typeface="Be Vietnam Pro" pitchFamily="34" charset="0"/>
-                <a:ea typeface="Be Vietnam Pro" pitchFamily="34" charset="-122"/>
-                <a:cs typeface="Be Vietnam Pro" pitchFamily="34" charset="-120"/>
-              </a:rPr>
-              <a:t> bộ</a:t>
-            </a:r>
-            <a:r>
-              <a:rPr lang="en-US" sz="2700" dirty="0" spc="-3" kern="0">
-                <a:solidFill>
-                  <a:srgbClr val="E4E1D8"/>
-                </a:solidFill>
-                <a:latin typeface="Be Vietnam Pro" pitchFamily="34" charset="0"/>
-                <a:ea typeface="Be Vietnam Pro" pitchFamily="34" charset="-122"/>
-                <a:cs typeface="Be Vietnam Pro" pitchFamily="34" charset="-120"/>
-              </a:rPr>
-              <a:t> nhớ</a:t>
-            </a:r>
-            <a:r>
-              <a:rPr lang="en-US" sz="2700" dirty="0" spc="-15" kern="0">
-                <a:solidFill>
-                  <a:srgbClr val="E4E1D8"/>
-                </a:solidFill>
-                <a:latin typeface="Be Vietnam Pro" pitchFamily="34" charset="0"/>
-                <a:ea typeface="Be Vietnam Pro" pitchFamily="34" charset="-122"/>
-                <a:cs typeface="Be Vietnam Pro" pitchFamily="34" charset="-120"/>
-              </a:rPr>
-              <a:t> gần</a:t>
-            </a:r>
-            <a:r>
-              <a:rPr lang="en-US" sz="2700" dirty="0" spc="-1" kern="0">
-                <a:solidFill>
-                  <a:srgbClr val="E4E1D8"/>
-                </a:solidFill>
-                <a:latin typeface="Be Vietnam Pro" pitchFamily="34" charset="0"/>
-                <a:ea typeface="Be Vietnam Pro" pitchFamily="34" charset="-122"/>
-                <a:cs typeface="Be Vietnam Pro" pitchFamily="34" charset="-120"/>
-              </a:rPr>
-              <a:t> như</a:t>
-            </a:r>
-            <a:r>
-              <a:rPr lang="en-US" sz="2700" dirty="0" spc="-2" kern="0">
-                <a:solidFill>
-                  <a:srgbClr val="E4E1D8"/>
-                </a:solidFill>
-                <a:latin typeface="Be Vietnam Pro" pitchFamily="34" charset="0"/>
-                <a:ea typeface="Be Vietnam Pro" pitchFamily="34" charset="-122"/>
-                <a:cs typeface="Be Vietnam Pro" pitchFamily="34" charset="-120"/>
-              </a:rPr>
-              <a:t> không giúp</a:t>
+              <a:t> chối</a:t>
             </a:r>
             <a:endParaRPr lang="en-US" sz="2700" dirty="0"/>
           </a:p>
@@ -9391,37 +9358,59 @@
               <a:buChar char="•"/>
             </a:pPr>
             <a:r>
-              <a:rPr lang="en-US" sz="2700" dirty="0" spc="-6" kern="0">
-                <a:solidFill>
-                  <a:srgbClr val="E4E1D8"/>
-                </a:solidFill>
-                <a:latin typeface="Be Vietnam Pro" pitchFamily="34" charset="0"/>
-                <a:ea typeface="Be Vietnam Pro" pitchFamily="34" charset="-122"/>
-                <a:cs typeface="Be Vietnam Pro" pitchFamily="34" charset="-120"/>
-              </a:rPr>
-              <a:t>noeviction:</a:t>
-            </a:r>
-            <a:r>
-              <a:rPr lang="en-US" sz="2700" dirty="0" spc="-20" kern="0">
-                <a:solidFill>
-                  <a:srgbClr val="E4E1D8"/>
-                </a:solidFill>
-                <a:latin typeface="Be Vietnam Pro" pitchFamily="34" charset="0"/>
-                <a:ea typeface="Be Vietnam Pro" pitchFamily="34" charset="-122"/>
-                <a:cs typeface="Be Vietnam Pro" pitchFamily="34" charset="-120"/>
-              </a:rPr>
-              <a:t> xem</a:t>
-            </a:r>
-            <a:r>
-              <a:rPr lang="en-US" sz="2700" dirty="0" spc="-13" kern="0">
-                <a:solidFill>
-                  <a:srgbClr val="E4E1D8"/>
-                </a:solidFill>
-                <a:latin typeface="Be Vietnam Pro" pitchFamily="34" charset="0"/>
-                <a:ea typeface="Be Vietnam Pro" pitchFamily="34" charset="-122"/>
-                <a:cs typeface="Be Vietnam Pro" pitchFamily="34" charset="-120"/>
-              </a:rPr>
-              <a:t> số</a:t>
+              <a:rPr lang="en-US" sz="2700" dirty="0" spc="1" kern="0">
+                <a:solidFill>
+                  <a:srgbClr val="E4E1D8"/>
+                </a:solidFill>
+                <a:latin typeface="Be Vietnam Pro" pitchFamily="34" charset="0"/>
+                <a:ea typeface="Be Vietnam Pro" pitchFamily="34" charset="-122"/>
+                <a:cs typeface="Be Vietnam Pro" pitchFamily="34" charset="-120"/>
+              </a:rPr>
+              <a:t>Có</a:t>
+            </a:r>
+            <a:r>
+              <a:rPr lang="en-US" sz="2700" dirty="0" spc="2" kern="0">
+                <a:solidFill>
+                  <a:srgbClr val="E4E1D8"/>
+                </a:solidFill>
+                <a:latin typeface="Be Vietnam Pro" pitchFamily="34" charset="0"/>
+                <a:ea typeface="Be Vietnam Pro" pitchFamily="34" charset="-122"/>
+                <a:cs typeface="Be Vietnam Pro" pitchFamily="34" charset="-120"/>
+              </a:rPr>
+              <a:t> đẩy</a:t>
+            </a:r>
+            <a:r>
+              <a:rPr lang="en-US" sz="2700" dirty="0" spc="-4" kern="0">
+                <a:solidFill>
+                  <a:srgbClr val="E4E1D8"/>
+                </a:solidFill>
+                <a:latin typeface="Be Vietnam Pro" pitchFamily="34" charset="0"/>
+                <a:ea typeface="Be Vietnam Pro" pitchFamily="34" charset="-122"/>
+                <a:cs typeface="Be Vietnam Pro" pitchFamily="34" charset="-120"/>
+              </a:rPr>
+              <a:t> khóa:</a:t>
+            </a:r>
+            <a:r>
+              <a:rPr lang="en-US" sz="2700" dirty="0" spc="-27" kern="0">
+                <a:solidFill>
+                  <a:srgbClr val="E4E1D8"/>
+                </a:solidFill>
+                <a:latin typeface="Be Vietnam Pro" pitchFamily="34" charset="0"/>
+                <a:ea typeface="Be Vietnam Pro" pitchFamily="34" charset="-122"/>
+                <a:cs typeface="Be Vietnam Pro" pitchFamily="34" charset="-120"/>
+              </a:rPr>
+              <a:t> evicted_keys</a:t>
+            </a:r>
+            <a:r>
+              <a:rPr lang="en-US" sz="2700" dirty="0" spc="-12" kern="0">
+                <a:solidFill>
+                  <a:srgbClr val="E4E1D8"/>
+                </a:solidFill>
+                <a:latin typeface="Be Vietnam Pro" pitchFamily="34" charset="0"/>
+                <a:ea typeface="Be Vietnam Pro" pitchFamily="34" charset="-122"/>
+                <a:cs typeface="Be Vietnam Pro" pitchFamily="34" charset="-120"/>
+              </a:rPr>
+              <a:t> tăng</a:t>
             </a:r>
             <a:r>
               <a:rPr lang="en-US" sz="2700" dirty="0" spc="-2" kern="0">
@@ -9432,18 +9421,7 @@
                 <a:ea typeface="Be Vietnam Pro" pitchFamily="34" charset="-122"/>
                 <a:cs typeface="Be Vietnam Pro" pitchFamily="34" charset="-120"/>
               </a:rPr>
-              <a:t> lệnh</a:t>
-            </a:r>
-            <a:r>
-              <a:rPr lang="en-US" sz="2700" dirty="0" spc="-4" kern="0">
-                <a:solidFill>
-                  <a:srgbClr val="E4E1D8"/>
-                </a:solidFill>
-                <a:latin typeface="Be Vietnam Pro" pitchFamily="34" charset="0"/>
-                <a:ea typeface="Be Vietnam Pro" pitchFamily="34" charset="-122"/>
-                <a:cs typeface="Be Vietnam Pro" pitchFamily="34" charset="-120"/>
-              </a:rPr>
-              <a:t> bị</a:t>
+              <a:t> nhanh thì</a:t>
             </a:r>
             <a:r>
               <a:rPr lang="en-US" sz="2700" dirty="0" spc="-1" kern="0">
@@ -9454,18 +9432,29 @@
                 <a:ea typeface="Be Vietnam Pro" pitchFamily="34" charset="-122"/>
                 <a:cs typeface="Be Vietnam Pro" pitchFamily="34" charset="-120"/>
               </a:rPr>
-              <a:t> từ</a:t>
-            </a:r>
-            <a:r>
-              <a:rPr lang="en-US" sz="2700" dirty="0" spc="0" kern="0">
-                <a:solidFill>
-                  <a:srgbClr val="E4E1D8"/>
-                </a:solidFill>
-                <a:latin typeface="Be Vietnam Pro" pitchFamily="34" charset="0"/>
-                <a:ea typeface="Be Vietnam Pro" pitchFamily="34" charset="-122"/>
-                <a:cs typeface="Be Vietnam Pro" pitchFamily="34" charset="-120"/>
-              </a:rPr>
-              <a:t> chối</a:t>
+              <a:t> thêm</a:t>
+            </a:r>
+            <a:r>
+              <a:rPr lang="en-US" sz="2700" dirty="0" spc="-7" kern="0">
+                <a:solidFill>
+                  <a:srgbClr val="E4E1D8"/>
+                </a:solidFill>
+                <a:latin typeface="Be Vietnam Pro" pitchFamily="34" charset="0"/>
+                <a:ea typeface="Be Vietnam Pro" pitchFamily="34" charset="-122"/>
+                <a:cs typeface="Be Vietnam Pro" pitchFamily="34" charset="-120"/>
+              </a:rPr>
+              <a:t> bộ</a:t>
+            </a:r>
+            <a:r>
+              <a:rPr lang="en-US" sz="2700" dirty="0" spc="-3" kern="0">
+                <a:solidFill>
+                  <a:srgbClr val="E4E1D8"/>
+                </a:solidFill>
+                <a:latin typeface="Be Vietnam Pro" pitchFamily="34" charset="0"/>
+                <a:ea typeface="Be Vietnam Pro" pitchFamily="34" charset="-122"/>
+                <a:cs typeface="Be Vietnam Pro" pitchFamily="34" charset="-120"/>
+              </a:rPr>
+              <a:t> nhớ</a:t>
             </a:r>
             <a:endParaRPr lang="en-US" sz="2700" dirty="0"/>
           </a:p>

</xml_diff>